<commit_message>
Update team members and enrollment numbers in PPT and Research Paper PDF
</commit_message>
<xml_diff>
--- a/PitchIQ_SilverOak_Presentation.pptx
+++ b/PitchIQ_SilverOak_Presentation.pptx
@@ -3307,8 +3307,8 @@
           <p:nvPr/>
         </p:nvGraphicFramePr>
         <p:xfrm>
-          <a:off x="1645920" y="3657600"/>
-          <a:ext cx="8899855" cy="2103120"/>
+          <a:off x="1280160" y="3474720"/>
+          <a:ext cx="9630460" cy="868680"/>
         </p:xfrm>
         <a:graphic>
           <a:graphicData uri="http://schemas.openxmlformats.org/drawingml/2006/table">
@@ -3317,17 +3317,19 @@
                 <a:tableStyleId>{5C22544A-7EE6-4342-B048-85BDC9FD1C3A}</a:tableStyleId>
               </a:tblPr>
               <a:tblGrid>
-                <a:gridCol w="2926080"/>
-                <a:gridCol w="5973775"/>
+                <a:gridCol w="1828800"/>
+                <a:gridCol w="2986430"/>
+                <a:gridCol w="1828800"/>
+                <a:gridCol w="2986430"/>
               </a:tblGrid>
-              <a:tr h="420624">
+              <a:tr h="434340">
                 <a:tc>
                   <a:txBody>
-                    <a:bodyPr/>
+                    <a:bodyPr tIns="54864" bIns="54864"/>
                     <a:lstStyle/>
                     <a:p>
                       <a:pPr>
-                        <a:defRPr sz="1200" b="1">
+                        <a:defRPr sz="1100" b="1">
                           <a:solidFill>
                             <a:srgbClr val="801818"/>
                           </a:solidFill>
@@ -3341,17 +3343,17 @@
                   </a:txBody>
                   <a:tcPr>
                     <a:solidFill>
-                      <a:srgbClr val="F1F5F9"/>
+                      <a:srgbClr val="F8FAFC"/>
                     </a:solidFill>
                   </a:tcPr>
                 </a:tc>
                 <a:tc>
                   <a:txBody>
-                    <a:bodyPr/>
+                    <a:bodyPr tIns="54864" bIns="54864"/>
                     <a:lstStyle/>
                     <a:p>
                       <a:pPr>
-                        <a:defRPr sz="1200">
+                        <a:defRPr sz="1100" b="0">
                           <a:solidFill>
                             <a:srgbClr val="1E293B"/>
                           </a:solidFill>
@@ -3365,19 +3367,17 @@
                   </a:txBody>
                   <a:tcPr>
                     <a:solidFill>
-                      <a:srgbClr val="F1F5F9"/>
+                      <a:srgbClr val="FFFFFF"/>
                     </a:solidFill>
                   </a:tcPr>
                 </a:tc>
-              </a:tr>
-              <a:tr h="420624">
                 <a:tc>
                   <a:txBody>
-                    <a:bodyPr/>
+                    <a:bodyPr tIns="54864" bIns="54864"/>
                     <a:lstStyle/>
                     <a:p>
                       <a:pPr>
-                        <a:defRPr sz="1200" b="1">
+                        <a:defRPr sz="1100" b="1">
                           <a:solidFill>
                             <a:srgbClr val="801818"/>
                           </a:solidFill>
@@ -3385,123 +3385,23 @@
                         </a:defRPr>
                       </a:pPr>
                       <a:r>
-                        <a:t>Enrollment No</a:t>
+                        <a:t>Branch</a:t>
                       </a:r>
                     </a:p>
                   </a:txBody>
                   <a:tcPr>
                     <a:solidFill>
-                      <a:srgbClr val="FFFFFF"/>
+                      <a:srgbClr val="F8FAFC"/>
                     </a:solidFill>
                   </a:tcPr>
                 </a:tc>
                 <a:tc>
                   <a:txBody>
-                    <a:bodyPr/>
+                    <a:bodyPr tIns="54864" bIns="54864"/>
                     <a:lstStyle/>
                     <a:p>
                       <a:pPr>
-                        <a:defRPr sz="1200">
-                          <a:solidFill>
-                            <a:srgbClr val="1E293B"/>
-                          </a:solidFill>
-                          <a:latin typeface="Arial"/>
-                        </a:defRPr>
-                      </a:pPr>
-                      <a:r>
-                        <a:t>[Your Enrollment Number]</a:t>
-                      </a:r>
-                    </a:p>
-                  </a:txBody>
-                  <a:tcPr>
-                    <a:solidFill>
-                      <a:srgbClr val="FFFFFF"/>
-                    </a:solidFill>
-                  </a:tcPr>
-                </a:tc>
-              </a:tr>
-              <a:tr h="420624">
-                <a:tc>
-                  <a:txBody>
-                    <a:bodyPr/>
-                    <a:lstStyle/>
-                    <a:p>
-                      <a:pPr>
-                        <a:defRPr sz="1200" b="1">
-                          <a:solidFill>
-                            <a:srgbClr val="801818"/>
-                          </a:solidFill>
-                          <a:latin typeface="Arial"/>
-                        </a:defRPr>
-                      </a:pPr>
-                      <a:r>
-                        <a:t>Student Name</a:t>
-                      </a:r>
-                    </a:p>
-                  </a:txBody>
-                  <a:tcPr>
-                    <a:solidFill>
-                      <a:srgbClr val="F1F5F9"/>
-                    </a:solidFill>
-                  </a:tcPr>
-                </a:tc>
-                <a:tc>
-                  <a:txBody>
-                    <a:bodyPr/>
-                    <a:lstStyle/>
-                    <a:p>
-                      <a:pPr>
-                        <a:defRPr sz="1200">
-                          <a:solidFill>
-                            <a:srgbClr val="1E293B"/>
-                          </a:solidFill>
-                          <a:latin typeface="Arial"/>
-                        </a:defRPr>
-                      </a:pPr>
-                      <a:r>
-                        <a:t>Parth Bavaliya</a:t>
-                      </a:r>
-                    </a:p>
-                  </a:txBody>
-                  <a:tcPr>
-                    <a:solidFill>
-                      <a:srgbClr val="F1F5F9"/>
-                    </a:solidFill>
-                  </a:tcPr>
-                </a:tc>
-              </a:tr>
-              <a:tr h="420624">
-                <a:tc>
-                  <a:txBody>
-                    <a:bodyPr/>
-                    <a:lstStyle/>
-                    <a:p>
-                      <a:pPr>
-                        <a:defRPr sz="1200" b="1">
-                          <a:solidFill>
-                            <a:srgbClr val="801818"/>
-                          </a:solidFill>
-                          <a:latin typeface="Arial"/>
-                        </a:defRPr>
-                      </a:pPr>
-                      <a:r>
-                        <a:t>Branch / Department</a:t>
-                      </a:r>
-                    </a:p>
-                  </a:txBody>
-                  <a:tcPr>
-                    <a:solidFill>
-                      <a:srgbClr val="FFFFFF"/>
-                    </a:solidFill>
-                  </a:tcPr>
-                </a:tc>
-                <a:tc>
-                  <a:txBody>
-                    <a:bodyPr/>
-                    <a:lstStyle/>
-                    <a:p>
-                      <a:pPr>
-                        <a:defRPr sz="1200">
+                        <a:defRPr sz="1100" b="0">
                           <a:solidFill>
                             <a:srgbClr val="1E293B"/>
                           </a:solidFill>
@@ -3520,14 +3420,14 @@
                   </a:tcPr>
                 </a:tc>
               </a:tr>
-              <a:tr h="420624">
+              <a:tr h="434340">
                 <a:tc>
                   <a:txBody>
-                    <a:bodyPr/>
+                    <a:bodyPr tIns="54864" bIns="54864"/>
                     <a:lstStyle/>
                     <a:p>
                       <a:pPr>
-                        <a:defRPr sz="1200" b="1">
+                        <a:defRPr sz="1100" b="1">
                           <a:solidFill>
                             <a:srgbClr val="801818"/>
                           </a:solidFill>
@@ -3535,7 +3435,230 @@
                         </a:defRPr>
                       </a:pPr>
                       <a:r>
-                        <a:t>Project Guide Name</a:t>
+                        <a:t>Project Guide</a:t>
+                      </a:r>
+                    </a:p>
+                  </a:txBody>
+                  <a:tcPr>
+                    <a:solidFill>
+                      <a:srgbClr val="F8FAFC"/>
+                    </a:solidFill>
+                  </a:tcPr>
+                </a:tc>
+                <a:tc>
+                  <a:txBody>
+                    <a:bodyPr tIns="54864" bIns="54864"/>
+                    <a:lstStyle/>
+                    <a:p>
+                      <a:pPr>
+                        <a:defRPr sz="1100" b="0">
+                          <a:solidFill>
+                            <a:srgbClr val="1E293B"/>
+                          </a:solidFill>
+                          <a:latin typeface="Arial"/>
+                        </a:defRPr>
+                      </a:pPr>
+                      <a:r>
+                        <a:t>[Prof. Guide Name]</a:t>
+                      </a:r>
+                    </a:p>
+                  </a:txBody>
+                  <a:tcPr>
+                    <a:solidFill>
+                      <a:srgbClr val="FFFFFF"/>
+                    </a:solidFill>
+                  </a:tcPr>
+                </a:tc>
+                <a:tc>
+                  <a:txBody>
+                    <a:bodyPr tIns="54864" bIns="54864"/>
+                    <a:lstStyle/>
+                    <a:p>
+                      <a:pPr>
+                        <a:defRPr sz="1100" b="1">
+                          <a:solidFill>
+                            <a:srgbClr val="801818"/>
+                          </a:solidFill>
+                          <a:latin typeface="Arial"/>
+                        </a:defRPr>
+                      </a:pPr>
+                      <a:r>
+                        <a:t>Department</a:t>
+                      </a:r>
+                    </a:p>
+                  </a:txBody>
+                  <a:tcPr>
+                    <a:solidFill>
+                      <a:srgbClr val="F8FAFC"/>
+                    </a:solidFill>
+                  </a:tcPr>
+                </a:tc>
+                <a:tc>
+                  <a:txBody>
+                    <a:bodyPr tIns="54864" bIns="54864"/>
+                    <a:lstStyle/>
+                    <a:p>
+                      <a:pPr>
+                        <a:defRPr sz="1100" b="0">
+                          <a:solidFill>
+                            <a:srgbClr val="1E293B"/>
+                          </a:solidFill>
+                          <a:latin typeface="Arial"/>
+                        </a:defRPr>
+                      </a:pPr>
+                      <a:r>
+                        <a:t>Computer Engineering, SOU</a:t>
+                      </a:r>
+                    </a:p>
+                  </a:txBody>
+                  <a:tcPr>
+                    <a:solidFill>
+                      <a:srgbClr val="FFFFFF"/>
+                    </a:solidFill>
+                  </a:tcPr>
+                </a:tc>
+              </a:tr>
+            </a:tbl>
+          </a:graphicData>
+        </a:graphic>
+      </p:graphicFrame>
+      <p:graphicFrame>
+        <p:nvGraphicFramePr>
+          <p:cNvPr id="7" name="Table 6"/>
+          <p:cNvGraphicFramePr>
+            <a:graphicFrameLocks noGrp="1"/>
+          </p:cNvGraphicFramePr>
+          <p:nvPr/>
+        </p:nvGraphicFramePr>
+        <p:xfrm>
+          <a:off x="1280160" y="4480560"/>
+          <a:ext cx="9631375" cy="1645920"/>
+        </p:xfrm>
+        <a:graphic>
+          <a:graphicData uri="http://schemas.openxmlformats.org/drawingml/2006/table">
+            <a:tbl>
+              <a:tblPr firstRow="1" bandRow="1">
+                <a:tableStyleId>{5C22544A-7EE6-4342-B048-85BDC9FD1C3A}</a:tableStyleId>
+              </a:tblPr>
+              <a:tblGrid>
+                <a:gridCol w="1097280"/>
+                <a:gridCol w="3962095"/>
+                <a:gridCol w="4572000"/>
+              </a:tblGrid>
+              <a:tr h="411480">
+                <a:tc>
+                  <a:txBody>
+                    <a:bodyPr/>
+                    <a:lstStyle/>
+                    <a:p>
+                      <a:pPr algn="ctr">
+                        <a:defRPr sz="1100" b="1">
+                          <a:solidFill>
+                            <a:srgbClr val="FFFFFF"/>
+                          </a:solidFill>
+                          <a:latin typeface="Arial"/>
+                        </a:defRPr>
+                      </a:pPr>
+                      <a:r>
+                        <a:t>Sr. No.</a:t>
+                      </a:r>
+                    </a:p>
+                  </a:txBody>
+                  <a:tcPr>
+                    <a:solidFill>
+                      <a:srgbClr val="801818"/>
+                    </a:solidFill>
+                  </a:tcPr>
+                </a:tc>
+                <a:tc>
+                  <a:txBody>
+                    <a:bodyPr/>
+                    <a:lstStyle/>
+                    <a:p>
+                      <a:pPr algn="ctr">
+                        <a:defRPr sz="1100" b="1">
+                          <a:solidFill>
+                            <a:srgbClr val="FFFFFF"/>
+                          </a:solidFill>
+                          <a:latin typeface="Arial"/>
+                        </a:defRPr>
+                      </a:pPr>
+                      <a:r>
+                        <a:t>Enrollment Number</a:t>
+                      </a:r>
+                    </a:p>
+                  </a:txBody>
+                  <a:tcPr>
+                    <a:solidFill>
+                      <a:srgbClr val="801818"/>
+                    </a:solidFill>
+                  </a:tcPr>
+                </a:tc>
+                <a:tc>
+                  <a:txBody>
+                    <a:bodyPr/>
+                    <a:lstStyle/>
+                    <a:p>
+                      <a:pPr>
+                        <a:defRPr sz="1100" b="1">
+                          <a:solidFill>
+                            <a:srgbClr val="FFFFFF"/>
+                          </a:solidFill>
+                          <a:latin typeface="Arial"/>
+                        </a:defRPr>
+                      </a:pPr>
+                      <a:r>
+                        <a:t>Student Name</a:t>
+                      </a:r>
+                    </a:p>
+                  </a:txBody>
+                  <a:tcPr>
+                    <a:solidFill>
+                      <a:srgbClr val="801818"/>
+                    </a:solidFill>
+                  </a:tcPr>
+                </a:tc>
+              </a:tr>
+              <a:tr h="411480">
+                <a:tc>
+                  <a:txBody>
+                    <a:bodyPr/>
+                    <a:lstStyle/>
+                    <a:p>
+                      <a:pPr algn="ctr">
+                        <a:defRPr sz="1100">
+                          <a:solidFill>
+                            <a:srgbClr val="1E293B"/>
+                          </a:solidFill>
+                          <a:latin typeface="Arial"/>
+                        </a:defRPr>
+                      </a:pPr>
+                      <a:r>
+                        <a:t>01</a:t>
+                      </a:r>
+                    </a:p>
+                  </a:txBody>
+                  <a:tcPr>
+                    <a:solidFill>
+                      <a:srgbClr val="F1F5F9"/>
+                    </a:solidFill>
+                  </a:tcPr>
+                </a:tc>
+                <a:tc>
+                  <a:txBody>
+                    <a:bodyPr/>
+                    <a:lstStyle/>
+                    <a:p>
+                      <a:pPr algn="ctr">
+                        <a:defRPr sz="1100">
+                          <a:solidFill>
+                            <a:srgbClr val="1E293B"/>
+                          </a:solidFill>
+                          <a:latin typeface="Arial"/>
+                        </a:defRPr>
+                      </a:pPr>
+                      <a:r>
+                        <a:t>2402031830036</a:t>
                       </a:r>
                     </a:p>
                   </a:txBody>
@@ -3551,7 +3674,7 @@
                     <a:lstStyle/>
                     <a:p>
                       <a:pPr>
-                        <a:defRPr sz="1200">
+                        <a:defRPr sz="1100" b="1">
                           <a:solidFill>
                             <a:srgbClr val="1E293B"/>
                           </a:solidFill>
@@ -3559,7 +3682,155 @@
                         </a:defRPr>
                       </a:pPr>
                       <a:r>
-                        <a:t>[Prof. Guide Name] / Internal Reviewer</a:t>
+                        <a:t>Parth Bavalliya</a:t>
+                      </a:r>
+                    </a:p>
+                  </a:txBody>
+                  <a:tcPr>
+                    <a:solidFill>
+                      <a:srgbClr val="F1F5F9"/>
+                    </a:solidFill>
+                  </a:tcPr>
+                </a:tc>
+              </a:tr>
+              <a:tr h="411480">
+                <a:tc>
+                  <a:txBody>
+                    <a:bodyPr/>
+                    <a:lstStyle/>
+                    <a:p>
+                      <a:pPr algn="ctr">
+                        <a:defRPr sz="1100">
+                          <a:solidFill>
+                            <a:srgbClr val="1E293B"/>
+                          </a:solidFill>
+                          <a:latin typeface="Arial"/>
+                        </a:defRPr>
+                      </a:pPr>
+                      <a:r>
+                        <a:t>02</a:t>
+                      </a:r>
+                    </a:p>
+                  </a:txBody>
+                  <a:tcPr>
+                    <a:solidFill>
+                      <a:srgbClr val="FFFFFF"/>
+                    </a:solidFill>
+                  </a:tcPr>
+                </a:tc>
+                <a:tc>
+                  <a:txBody>
+                    <a:bodyPr/>
+                    <a:lstStyle/>
+                    <a:p>
+                      <a:pPr algn="ctr">
+                        <a:defRPr sz="1100">
+                          <a:solidFill>
+                            <a:srgbClr val="1E293B"/>
+                          </a:solidFill>
+                          <a:latin typeface="Arial"/>
+                        </a:defRPr>
+                      </a:pPr>
+                      <a:r>
+                        <a:t>2402031830026</a:t>
+                      </a:r>
+                    </a:p>
+                  </a:txBody>
+                  <a:tcPr>
+                    <a:solidFill>
+                      <a:srgbClr val="FFFFFF"/>
+                    </a:solidFill>
+                  </a:tcPr>
+                </a:tc>
+                <a:tc>
+                  <a:txBody>
+                    <a:bodyPr/>
+                    <a:lstStyle/>
+                    <a:p>
+                      <a:pPr>
+                        <a:defRPr sz="1100" b="1">
+                          <a:solidFill>
+                            <a:srgbClr val="1E293B"/>
+                          </a:solidFill>
+                          <a:latin typeface="Arial"/>
+                        </a:defRPr>
+                      </a:pPr>
+                      <a:r>
+                        <a:t>Harsh Varatiya</a:t>
+                      </a:r>
+                    </a:p>
+                  </a:txBody>
+                  <a:tcPr>
+                    <a:solidFill>
+                      <a:srgbClr val="FFFFFF"/>
+                    </a:solidFill>
+                  </a:tcPr>
+                </a:tc>
+              </a:tr>
+              <a:tr h="411480">
+                <a:tc>
+                  <a:txBody>
+                    <a:bodyPr/>
+                    <a:lstStyle/>
+                    <a:p>
+                      <a:pPr algn="ctr">
+                        <a:defRPr sz="1100">
+                          <a:solidFill>
+                            <a:srgbClr val="1E293B"/>
+                          </a:solidFill>
+                          <a:latin typeface="Arial"/>
+                        </a:defRPr>
+                      </a:pPr>
+                      <a:r>
+                        <a:t>03</a:t>
+                      </a:r>
+                    </a:p>
+                  </a:txBody>
+                  <a:tcPr>
+                    <a:solidFill>
+                      <a:srgbClr val="F1F5F9"/>
+                    </a:solidFill>
+                  </a:tcPr>
+                </a:tc>
+                <a:tc>
+                  <a:txBody>
+                    <a:bodyPr/>
+                    <a:lstStyle/>
+                    <a:p>
+                      <a:pPr algn="ctr">
+                        <a:defRPr sz="1100">
+                          <a:solidFill>
+                            <a:srgbClr val="1E293B"/>
+                          </a:solidFill>
+                          <a:latin typeface="Arial"/>
+                        </a:defRPr>
+                      </a:pPr>
+                      <a:r>
+                        <a:t>2402031830015</a:t>
+                      </a:r>
+                    </a:p>
+                  </a:txBody>
+                  <a:tcPr>
+                    <a:solidFill>
+                      <a:srgbClr val="F1F5F9"/>
+                    </a:solidFill>
+                  </a:tcPr>
+                </a:tc>
+                <a:tc>
+                  <a:txBody>
+                    <a:bodyPr/>
+                    <a:lstStyle/>
+                    <a:p>
+                      <a:pPr>
+                        <a:defRPr sz="1100" b="1">
+                          <a:solidFill>
+                            <a:srgbClr val="1E293B"/>
+                          </a:solidFill>
+                          <a:latin typeface="Arial"/>
+                        </a:defRPr>
+                      </a:pPr>
+                      <a:r>
+                        <a:t>Akshat Solanki</a:t>
                       </a:r>
                     </a:p>
                   </a:txBody>

</xml_diff>

<commit_message>
Update Project Guide to Prof. Hemali Patel in PPT
</commit_message>
<xml_diff>
--- a/PitchIQ_SilverOak_Presentation.pptx
+++ b/PitchIQ_SilverOak_Presentation.pptx
@@ -3451,21 +3451,21 @@
                     <a:lstStyle/>
                     <a:p>
                       <a:pPr>
-                        <a:defRPr sz="1100" b="0">
+                        <a:defRPr sz="1100" b="1">
                           <a:solidFill>
-                            <a:srgbClr val="1E293B"/>
+                            <a:srgbClr val="801818"/>
                           </a:solidFill>
                           <a:latin typeface="Arial"/>
                         </a:defRPr>
                       </a:pPr>
                       <a:r>
-                        <a:t>[Prof. Guide Name]</a:t>
+                        <a:t>Prof. Hemali Patel</a:t>
                       </a:r>
                     </a:p>
                   </a:txBody>
                   <a:tcPr>
                     <a:solidFill>
-                      <a:srgbClr val="FFFFFF"/>
+                      <a:srgbClr val="F8FAFC"/>
                     </a:solidFill>
                   </a:tcPr>
                 </a:tc>

</xml_diff>

<commit_message>
Update Project ID to M2_CSE_027 in PPT and Research Paper PDF
</commit_message>
<xml_diff>
--- a/PitchIQ_SilverOak_Presentation.pptx
+++ b/PitchIQ_SilverOak_Presentation.pptx
@@ -3353,7 +3353,7 @@
                     <a:lstStyle/>
                     <a:p>
                       <a:pPr>
-                        <a:defRPr sz="1100" b="0">
+                        <a:defRPr sz="1100" b="1">
                           <a:solidFill>
                             <a:srgbClr val="1E293B"/>
                           </a:solidFill>
@@ -3361,13 +3361,13 @@
                         </a:defRPr>
                       </a:pPr>
                       <a:r>
-                        <a:t>CE-2026-PIQ-01</a:t>
+                        <a:t>M2_CSE_027</a:t>
                       </a:r>
                     </a:p>
                   </a:txBody>
                   <a:tcPr>
                     <a:solidFill>
-                      <a:srgbClr val="FFFFFF"/>
+                      <a:srgbClr val="F8FAFC"/>
                     </a:solidFill>
                   </a:tcPr>
                 </a:tc>

</xml_diff>